<commit_message>
mise à jour de la présentaion
</commit_message>
<xml_diff>
--- a/video et fichiers à publier/Presentation_DevOps_TaskManager_Microservices.pptx
+++ b/video et fichiers à publier/Presentation_DevOps_TaskManager_Microservices.pptx
@@ -13,9 +13,10 @@
     <p:sldId id="266" r:id="rId7"/>
     <p:sldId id="265" r:id="rId8"/>
     <p:sldId id="261" r:id="rId9"/>
-    <p:sldId id="267" r:id="rId10"/>
-    <p:sldId id="262" r:id="rId11"/>
-    <p:sldId id="263" r:id="rId12"/>
+    <p:sldId id="268" r:id="rId10"/>
+    <p:sldId id="267" r:id="rId11"/>
+    <p:sldId id="262" r:id="rId12"/>
+    <p:sldId id="263" r:id="rId13"/>
   </p:sldIdLst>
   <p:sldSz cx="12188825" cy="6858000"/>
   <p:notesSz cx="6858000" cy="9144000"/>
@@ -298,7 +299,7 @@
           <a:p>
             <a:fld id="{5BCAD085-E8A6-8845-BD4E-CB4CCA059FC4}" type="datetimeFigureOut">
               <a:rPr lang="en-US" smtClean="0"/>
-              <a:t>7/14/2026</a:t>
+              <a:t>7/16/2026</a:t>
             </a:fld>
             <a:endParaRPr lang="en-US"/>
           </a:p>
@@ -468,7 +469,7 @@
           <a:p>
             <a:fld id="{5BCAD085-E8A6-8845-BD4E-CB4CCA059FC4}" type="datetimeFigureOut">
               <a:rPr lang="en-US" smtClean="0"/>
-              <a:t>7/14/2026</a:t>
+              <a:t>7/16/2026</a:t>
             </a:fld>
             <a:endParaRPr lang="en-US"/>
           </a:p>
@@ -648,7 +649,7 @@
           <a:p>
             <a:fld id="{5BCAD085-E8A6-8845-BD4E-CB4CCA059FC4}" type="datetimeFigureOut">
               <a:rPr lang="en-US" smtClean="0"/>
-              <a:t>7/14/2026</a:t>
+              <a:t>7/16/2026</a:t>
             </a:fld>
             <a:endParaRPr lang="en-US"/>
           </a:p>
@@ -818,7 +819,7 @@
           <a:p>
             <a:fld id="{5BCAD085-E8A6-8845-BD4E-CB4CCA059FC4}" type="datetimeFigureOut">
               <a:rPr lang="en-US" smtClean="0"/>
-              <a:t>7/14/2026</a:t>
+              <a:t>7/16/2026</a:t>
             </a:fld>
             <a:endParaRPr lang="en-US"/>
           </a:p>
@@ -1064,7 +1065,7 @@
           <a:p>
             <a:fld id="{5BCAD085-E8A6-8845-BD4E-CB4CCA059FC4}" type="datetimeFigureOut">
               <a:rPr lang="en-US" smtClean="0"/>
-              <a:t>7/14/2026</a:t>
+              <a:t>7/16/2026</a:t>
             </a:fld>
             <a:endParaRPr lang="en-US"/>
           </a:p>
@@ -1352,7 +1353,7 @@
           <a:p>
             <a:fld id="{5BCAD085-E8A6-8845-BD4E-CB4CCA059FC4}" type="datetimeFigureOut">
               <a:rPr lang="en-US" smtClean="0"/>
-              <a:t>7/14/2026</a:t>
+              <a:t>7/16/2026</a:t>
             </a:fld>
             <a:endParaRPr lang="en-US"/>
           </a:p>
@@ -1774,7 +1775,7 @@
           <a:p>
             <a:fld id="{5BCAD085-E8A6-8845-BD4E-CB4CCA059FC4}" type="datetimeFigureOut">
               <a:rPr lang="en-US" smtClean="0"/>
-              <a:t>7/14/2026</a:t>
+              <a:t>7/16/2026</a:t>
             </a:fld>
             <a:endParaRPr lang="en-US"/>
           </a:p>
@@ -1892,7 +1893,7 @@
           <a:p>
             <a:fld id="{5BCAD085-E8A6-8845-BD4E-CB4CCA059FC4}" type="datetimeFigureOut">
               <a:rPr lang="en-US" smtClean="0"/>
-              <a:t>7/14/2026</a:t>
+              <a:t>7/16/2026</a:t>
             </a:fld>
             <a:endParaRPr lang="en-US"/>
           </a:p>
@@ -1987,7 +1988,7 @@
           <a:p>
             <a:fld id="{5BCAD085-E8A6-8845-BD4E-CB4CCA059FC4}" type="datetimeFigureOut">
               <a:rPr lang="en-US" smtClean="0"/>
-              <a:t>7/14/2026</a:t>
+              <a:t>7/16/2026</a:t>
             </a:fld>
             <a:endParaRPr lang="en-US"/>
           </a:p>
@@ -2264,7 +2265,7 @@
           <a:p>
             <a:fld id="{5BCAD085-E8A6-8845-BD4E-CB4CCA059FC4}" type="datetimeFigureOut">
               <a:rPr lang="en-US" smtClean="0"/>
-              <a:t>7/14/2026</a:t>
+              <a:t>7/16/2026</a:t>
             </a:fld>
             <a:endParaRPr lang="en-US"/>
           </a:p>
@@ -2517,7 +2518,7 @@
           <a:p>
             <a:fld id="{5BCAD085-E8A6-8845-BD4E-CB4CCA059FC4}" type="datetimeFigureOut">
               <a:rPr lang="en-US" smtClean="0"/>
-              <a:t>7/14/2026</a:t>
+              <a:t>7/16/2026</a:t>
             </a:fld>
             <a:endParaRPr lang="en-US"/>
           </a:p>
@@ -2730,7 +2731,7 @@
           <a:p>
             <a:fld id="{5BCAD085-E8A6-8845-BD4E-CB4CCA059FC4}" type="datetimeFigureOut">
               <a:rPr lang="en-US" smtClean="0"/>
-              <a:t>7/14/2026</a:t>
+              <a:t>7/16/2026</a:t>
             </a:fld>
             <a:endParaRPr lang="en-US"/>
           </a:p>
@@ -3194,7 +3195,7 @@
       </p:grpSpPr>
       <p:sp>
         <p:nvSpPr>
-          <p:cNvPr id="2" name="Title 1"/>
+          <p:cNvPr id="2" name="Titre 1"/>
           <p:cNvSpPr>
             <a:spLocks noGrp="1"/>
           </p:cNvSpPr>
@@ -3202,95 +3203,192 @@
             <p:ph type="title"/>
           </p:nvPr>
         </p:nvSpPr>
-        <p:spPr/>
-        <p:txBody>
-          <a:bodyPr/>
-          <a:lstStyle/>
-          <a:p>
-            <a:r>
-              <a:t>Chaîne CI/CD</a:t>
-            </a:r>
-          </a:p>
-        </p:txBody>
-      </p:sp>
-      <p:sp>
-        <p:nvSpPr>
-          <p:cNvPr id="3" name="Content Placeholder 2"/>
-          <p:cNvSpPr>
-            <a:spLocks noGrp="1"/>
-          </p:cNvSpPr>
-          <p:nvPr>
-            <p:ph idx="1"/>
-          </p:nvPr>
-        </p:nvSpPr>
-        <p:spPr/>
-        <p:txBody>
-          <a:bodyPr/>
-          <a:lstStyle/>
-          <a:p>
-            <a:pPr>
-              <a:defRPr sz="2200"/>
-            </a:pPr>
-            <a:endParaRPr lang="fr-FR" dirty="0" smtClean="0"/>
-          </a:p>
-          <a:p>
-            <a:pPr>
-              <a:defRPr sz="2200"/>
-            </a:pPr>
-            <a:endParaRPr lang="fr-FR" dirty="0"/>
-          </a:p>
-          <a:p>
-            <a:pPr>
-              <a:defRPr sz="2200"/>
-            </a:pPr>
-            <a:endParaRPr dirty="0"/>
-          </a:p>
-          <a:p>
-            <a:pPr>
-              <a:defRPr sz="2200"/>
-            </a:pPr>
-            <a:r>
-              <a:rPr dirty="0" err="1"/>
-              <a:t>Déploiement</a:t>
-            </a:r>
-            <a:r>
-              <a:rPr dirty="0"/>
-              <a:t> </a:t>
-            </a:r>
-            <a:r>
-              <a:rPr dirty="0" err="1"/>
-              <a:t>automatisé</a:t>
-            </a:r>
-            <a:r>
-              <a:rPr dirty="0"/>
-              <a:t> après validation des tests</a:t>
-            </a:r>
-          </a:p>
-        </p:txBody>
-      </p:sp>
-      <p:pic>
-        <p:nvPicPr>
-          <p:cNvPr id="4" name="Picture 2"/>
-          <p:cNvPicPr/>
-          <p:nvPr/>
-        </p:nvPicPr>
-        <p:blipFill>
-          <a:blip r:embed="rId2"/>
-          <a:stretch>
-            <a:fillRect/>
-          </a:stretch>
-        </p:blipFill>
         <p:spPr>
           <a:xfrm>
-            <a:off x="569343" y="1706622"/>
-            <a:ext cx="6623050" cy="834390"/>
+            <a:off x="457200" y="274638"/>
+            <a:ext cx="8229600" cy="786411"/>
           </a:xfrm>
-          <a:prstGeom prst="rect">
-            <a:avLst/>
-          </a:prstGeom>
         </p:spPr>
-      </p:pic>
+        <p:txBody>
+          <a:bodyPr/>
+          <a:lstStyle/>
+          <a:p>
+            <a:r>
+              <a:rPr lang="fr-FR" dirty="0"/>
+              <a:t>Fichiers </a:t>
+            </a:r>
+            <a:r>
+              <a:rPr lang="fr-FR" dirty="0" err="1"/>
+              <a:t>DevOps</a:t>
+            </a:r>
+            <a:r>
+              <a:rPr lang="fr-FR" dirty="0"/>
+              <a:t> </a:t>
+            </a:r>
+            <a:r>
+              <a:rPr lang="fr-FR" dirty="0" smtClean="0"/>
+              <a:t>(2)</a:t>
+            </a:r>
+            <a:endParaRPr lang="fr-FR" dirty="0"/>
+          </a:p>
+        </p:txBody>
+      </p:sp>
+      <p:sp>
+        <p:nvSpPr>
+          <p:cNvPr id="3" name="Espace réservé du contenu 2"/>
+          <p:cNvSpPr>
+            <a:spLocks noGrp="1"/>
+          </p:cNvSpPr>
+          <p:nvPr>
+            <p:ph idx="1"/>
+          </p:nvPr>
+        </p:nvSpPr>
+        <p:spPr>
+          <a:xfrm>
+            <a:off x="457200" y="1155940"/>
+            <a:ext cx="8229600" cy="4970224"/>
+          </a:xfrm>
+        </p:spPr>
+        <p:txBody>
+          <a:bodyPr>
+            <a:normAutofit/>
+          </a:bodyPr>
+          <a:lstStyle/>
+          <a:p>
+            <a:pPr>
+              <a:defRPr sz="2200"/>
+            </a:pPr>
+            <a:r>
+              <a:rPr lang="fr-FR" dirty="0"/>
+              <a:t>devops_files.py et </a:t>
+            </a:r>
+            <a:r>
+              <a:rPr lang="fr-FR" dirty="0" smtClean="0"/>
+              <a:t>devops_ci.py</a:t>
+            </a:r>
+          </a:p>
+          <a:p>
+            <a:pPr marL="0" indent="0">
+              <a:buNone/>
+              <a:defRPr sz="2200"/>
+            </a:pPr>
+            <a:r>
+              <a:rPr lang="fr-FR" sz="1600" dirty="0"/>
+              <a:t>Le script </a:t>
+            </a:r>
+            <a:r>
+              <a:rPr lang="fr-FR" sz="1600" b="1" dirty="0"/>
+              <a:t>devops_files.py</a:t>
+            </a:r>
+            <a:r>
+              <a:rPr lang="fr-FR" sz="1600" dirty="0"/>
+              <a:t> prépare automatiquement les fichiers nécessaires au déploiement </a:t>
+            </a:r>
+            <a:r>
+              <a:rPr lang="fr-FR" sz="1600" dirty="0" err="1"/>
+              <a:t>DevOps</a:t>
+            </a:r>
+            <a:r>
+              <a:rPr lang="fr-FR" sz="1600" dirty="0"/>
+              <a:t>. Il génère, copie ou organise les ressources et les fichiers de configuration utilisés par Docker, </a:t>
+            </a:r>
+            <a:r>
+              <a:rPr lang="fr-FR" sz="1600" dirty="0" err="1"/>
+              <a:t>Kubernetes</a:t>
+            </a:r>
+            <a:r>
+              <a:rPr lang="fr-FR" sz="1600" dirty="0"/>
+              <a:t> et </a:t>
+            </a:r>
+            <a:r>
+              <a:rPr lang="fr-FR" sz="1600" dirty="0" err="1"/>
+              <a:t>GitHub</a:t>
+            </a:r>
+            <a:r>
+              <a:rPr lang="fr-FR" sz="1600" dirty="0"/>
+              <a:t> Actions. </a:t>
+            </a:r>
+          </a:p>
+          <a:p>
+            <a:pPr>
+              <a:defRPr sz="2200"/>
+            </a:pPr>
+            <a:endParaRPr lang="fr-FR" sz="1600" dirty="0"/>
+          </a:p>
+          <a:p>
+            <a:pPr marL="0" indent="0">
+              <a:buNone/>
+              <a:defRPr sz="2200"/>
+            </a:pPr>
+            <a:r>
+              <a:rPr lang="fr-FR" sz="1600" dirty="0"/>
+              <a:t>Le script </a:t>
+            </a:r>
+            <a:r>
+              <a:rPr lang="fr-FR" sz="1600" b="1" dirty="0"/>
+              <a:t>devops_ci.py</a:t>
+            </a:r>
+            <a:r>
+              <a:rPr lang="fr-FR" sz="1600" dirty="0"/>
+              <a:t> automatise certaines étapes de l'intégration continue, comme la préparation des </a:t>
+            </a:r>
+            <a:r>
+              <a:rPr lang="fr-FR" sz="1600" dirty="0" err="1"/>
+              <a:t>builds</a:t>
+            </a:r>
+            <a:r>
+              <a:rPr lang="fr-FR" sz="1600" dirty="0"/>
+              <a:t>, les vérifications ou l'exécution de tâches techniques avant le lancement du pipeline CI/CD. Il simplifie et standardise le processus de déploiement. </a:t>
+            </a:r>
+          </a:p>
+          <a:p>
+            <a:pPr>
+              <a:defRPr sz="2200"/>
+            </a:pPr>
+            <a:endParaRPr lang="fr-FR" dirty="0"/>
+          </a:p>
+          <a:p>
+            <a:pPr>
+              <a:defRPr sz="2200"/>
+            </a:pPr>
+            <a:r>
+              <a:rPr lang="fr-FR" dirty="0"/>
+              <a:t>.</a:t>
+            </a:r>
+            <a:r>
+              <a:rPr lang="fr-FR" dirty="0" err="1"/>
+              <a:t>env</a:t>
+            </a:r>
+            <a:r>
+              <a:rPr lang="fr-FR" dirty="0"/>
+              <a:t> et application-*.</a:t>
+            </a:r>
+            <a:r>
+              <a:rPr lang="fr-FR" dirty="0" err="1"/>
+              <a:t>yml</a:t>
+            </a:r>
+            <a:endParaRPr lang="fr-FR" dirty="0"/>
+          </a:p>
+          <a:p>
+            <a:pPr marL="0" indent="0">
+              <a:buNone/>
+            </a:pPr>
+            <a:r>
+              <a:rPr lang="fr-FR" sz="1700" dirty="0"/>
+              <a:t>centralise les variables d'environnement de l'application, telles que les ports, les mots de passe, les URL des services ou les paramètres de base de données. Il permet de modifier la configuration sans changer le code source. </a:t>
+            </a:r>
+          </a:p>
+          <a:p>
+            <a:endParaRPr lang="fr-FR" dirty="0"/>
+          </a:p>
+        </p:txBody>
+      </p:sp>
     </p:spTree>
+    <p:extLst>
+      <p:ext uri="{BB962C8B-B14F-4D97-AF65-F5344CB8AC3E}">
+        <p14:creationId xmlns:p14="http://schemas.microsoft.com/office/powerpoint/2010/main" val="3472314947"/>
+      </p:ext>
+    </p:extLst>
   </p:cSld>
   <p:clrMapOvr>
     <a:masterClrMapping/>
@@ -3338,35 +3436,218 @@
           <a:lstStyle/>
           <a:p>
             <a:r>
-              <a:t>Conclusion</a:t>
-            </a:r>
-          </a:p>
-        </p:txBody>
-      </p:sp>
-      <p:sp>
-        <p:nvSpPr>
-          <p:cNvPr id="3" name="Content Placeholder 2"/>
-          <p:cNvSpPr>
-            <a:spLocks noGrp="1"/>
-          </p:cNvSpPr>
-          <p:nvPr>
-            <p:ph idx="1"/>
-          </p:nvPr>
-        </p:nvSpPr>
-        <p:spPr/>
-        <p:txBody>
-          <a:bodyPr/>
-          <a:lstStyle/>
-          <a:p>
-            <a:pPr>
-              <a:defRPr sz="2200"/>
-            </a:pPr>
-            <a:r>
               <a:rPr dirty="0" err="1"/>
               <a:t>Chaîne</a:t>
             </a:r>
             <a:r>
               <a:rPr dirty="0"/>
+              <a:t> CI/CD</a:t>
+            </a:r>
+          </a:p>
+        </p:txBody>
+      </p:sp>
+      <p:sp>
+        <p:nvSpPr>
+          <p:cNvPr id="3" name="Content Placeholder 2"/>
+          <p:cNvSpPr>
+            <a:spLocks noGrp="1"/>
+          </p:cNvSpPr>
+          <p:nvPr>
+            <p:ph idx="1"/>
+          </p:nvPr>
+        </p:nvSpPr>
+        <p:spPr/>
+        <p:txBody>
+          <a:bodyPr/>
+          <a:lstStyle/>
+          <a:p>
+            <a:pPr>
+              <a:defRPr sz="2200"/>
+            </a:pPr>
+            <a:endParaRPr lang="fr-FR" dirty="0" smtClean="0"/>
+          </a:p>
+          <a:p>
+            <a:pPr>
+              <a:defRPr sz="2200"/>
+            </a:pPr>
+            <a:endParaRPr lang="fr-FR" dirty="0"/>
+          </a:p>
+          <a:p>
+            <a:pPr>
+              <a:defRPr sz="2200"/>
+            </a:pPr>
+            <a:endParaRPr lang="fr-FR" dirty="0" smtClean="0"/>
+          </a:p>
+          <a:p>
+            <a:pPr>
+              <a:defRPr sz="2200"/>
+            </a:pPr>
+            <a:endParaRPr lang="fr-FR" dirty="0"/>
+          </a:p>
+          <a:p>
+            <a:pPr>
+              <a:defRPr sz="2200"/>
+            </a:pPr>
+            <a:r>
+              <a:rPr dirty="0" err="1" smtClean="0"/>
+              <a:t>Déploiement</a:t>
+            </a:r>
+            <a:r>
+              <a:rPr dirty="0" smtClean="0"/>
+              <a:t> </a:t>
+            </a:r>
+            <a:r>
+              <a:rPr dirty="0" err="1"/>
+              <a:t>automatisé</a:t>
+            </a:r>
+            <a:r>
+              <a:rPr dirty="0"/>
+              <a:t> après validation des tests</a:t>
+            </a:r>
+          </a:p>
+        </p:txBody>
+      </p:sp>
+      <p:pic>
+        <p:nvPicPr>
+          <p:cNvPr id="2051" name="Picture 3"/>
+          <p:cNvPicPr>
+            <a:picLocks noChangeAspect="1" noChangeArrowheads="1"/>
+          </p:cNvPicPr>
+          <p:nvPr/>
+        </p:nvPicPr>
+        <p:blipFill>
+          <a:blip r:embed="rId2">
+            <a:extLst>
+              <a:ext uri="{28A0092B-C50C-407E-A947-70E740481C1C}">
+                <a14:useLocalDpi xmlns:a14="http://schemas.microsoft.com/office/drawing/2010/main" val="0"/>
+              </a:ext>
+            </a:extLst>
+          </a:blip>
+          <a:srcRect/>
+          <a:stretch>
+            <a:fillRect/>
+          </a:stretch>
+        </p:blipFill>
+        <p:spPr bwMode="auto">
+          <a:xfrm>
+            <a:off x="536980" y="1251283"/>
+            <a:ext cx="9329057" cy="1619597"/>
+          </a:xfrm>
+          <a:prstGeom prst="rect">
+            <a:avLst/>
+          </a:prstGeom>
+          <a:noFill/>
+          <a:ln>
+            <a:noFill/>
+          </a:ln>
+          <a:effectLst/>
+          <a:extLst>
+            <a:ext uri="{909E8E84-426E-40DD-AFC4-6F175D3DCCD1}">
+              <a14:hiddenFill xmlns:a14="http://schemas.microsoft.com/office/drawing/2010/main">
+                <a:solidFill>
+                  <a:schemeClr val="accent1"/>
+                </a:solidFill>
+              </a14:hiddenFill>
+            </a:ext>
+            <a:ext uri="{91240B29-F687-4F45-9708-019B960494DF}">
+              <a14:hiddenLine xmlns:a14="http://schemas.microsoft.com/office/drawing/2010/main" w="9525">
+                <a:solidFill>
+                  <a:schemeClr val="tx1"/>
+                </a:solidFill>
+                <a:miter lim="800000"/>
+                <a:headEnd/>
+                <a:tailEnd/>
+              </a14:hiddenLine>
+            </a:ext>
+            <a:ext uri="{AF507438-7753-43E0-B8FC-AC1667EBCBE1}">
+              <a14:hiddenEffects xmlns:a14="http://schemas.microsoft.com/office/drawing/2010/main">
+                <a:effectLst>
+                  <a:outerShdw dist="35921" dir="2700000" algn="ctr" rotWithShape="0">
+                    <a:schemeClr val="bg2"/>
+                  </a:outerShdw>
+                </a:effectLst>
+              </a14:hiddenEffects>
+            </a:ext>
+          </a:extLst>
+        </p:spPr>
+      </p:pic>
+    </p:spTree>
+  </p:cSld>
+  <p:clrMapOvr>
+    <a:masterClrMapping/>
+  </p:clrMapOvr>
+  <p:timing>
+    <p:tnLst>
+      <p:par>
+        <p:cTn id="1" dur="indefinite" restart="never" nodeType="tmRoot"/>
+      </p:par>
+    </p:tnLst>
+  </p:timing>
+</p:sld>
+</file>
+
+<file path=ppt/slides/slide12.xml><?xml version="1.0" encoding="utf-8"?>
+<p:sld xmlns:a="http://schemas.openxmlformats.org/drawingml/2006/main" xmlns:r="http://schemas.openxmlformats.org/officeDocument/2006/relationships" xmlns:p="http://schemas.openxmlformats.org/presentationml/2006/main">
+  <p:cSld>
+    <p:spTree>
+      <p:nvGrpSpPr>
+        <p:cNvPr id="1" name=""/>
+        <p:cNvGrpSpPr/>
+        <p:nvPr/>
+      </p:nvGrpSpPr>
+      <p:grpSpPr>
+        <a:xfrm>
+          <a:off x="0" y="0"/>
+          <a:ext cx="0" cy="0"/>
+          <a:chOff x="0" y="0"/>
+          <a:chExt cx="0" cy="0"/>
+        </a:xfrm>
+      </p:grpSpPr>
+      <p:sp>
+        <p:nvSpPr>
+          <p:cNvPr id="2" name="Title 1"/>
+          <p:cNvSpPr>
+            <a:spLocks noGrp="1"/>
+          </p:cNvSpPr>
+          <p:nvPr>
+            <p:ph type="title"/>
+          </p:nvPr>
+        </p:nvSpPr>
+        <p:spPr/>
+        <p:txBody>
+          <a:bodyPr/>
+          <a:lstStyle/>
+          <a:p>
+            <a:r>
+              <a:t>Conclusion</a:t>
+            </a:r>
+          </a:p>
+        </p:txBody>
+      </p:sp>
+      <p:sp>
+        <p:nvSpPr>
+          <p:cNvPr id="3" name="Content Placeholder 2"/>
+          <p:cNvSpPr>
+            <a:spLocks noGrp="1"/>
+          </p:cNvSpPr>
+          <p:nvPr>
+            <p:ph idx="1"/>
+          </p:nvPr>
+        </p:nvSpPr>
+        <p:spPr/>
+        <p:txBody>
+          <a:bodyPr/>
+          <a:lstStyle/>
+          <a:p>
+            <a:pPr>
+              <a:defRPr sz="2200"/>
+            </a:pPr>
+            <a:r>
+              <a:rPr dirty="0" err="1"/>
+              <a:t>Chaîne</a:t>
+            </a:r>
+            <a:r>
+              <a:rPr dirty="0"/>
               <a:t> DevOps </a:t>
             </a:r>
             <a:r>
@@ -3421,9 +3702,16 @@
               <a:t> et </a:t>
             </a:r>
             <a:r>
-              <a:rPr dirty="0" err="1"/>
+              <a:rPr dirty="0" err="1" smtClean="0"/>
               <a:t>reproductible</a:t>
             </a:r>
+            <a:endParaRPr lang="fr-FR" dirty="0" smtClean="0"/>
+          </a:p>
+          <a:p>
+            <a:pPr marL="0" indent="0">
+              <a:buNone/>
+              <a:defRPr sz="2200"/>
+            </a:pPr>
             <a:endParaRPr dirty="0"/>
           </a:p>
         </p:txBody>
@@ -3633,13 +3921,28 @@
         </p:nvSpPr>
         <p:spPr/>
         <p:txBody>
-          <a:bodyPr/>
+          <a:bodyPr>
+            <a:normAutofit fontScale="90000"/>
+          </a:bodyPr>
           <a:lstStyle/>
           <a:p>
             <a:r>
               <a:rPr dirty="0"/>
-              <a:t>Architecture DevOps</a:t>
-            </a:r>
+              <a:t>Architecture </a:t>
+            </a:r>
+            <a:r>
+              <a:rPr dirty="0" smtClean="0"/>
+              <a:t>DevOps</a:t>
+            </a:r>
+            <a:r>
+              <a:rPr lang="fr-FR" dirty="0" smtClean="0"/>
+              <a:t> de </a:t>
+            </a:r>
+            <a:r>
+              <a:rPr lang="fr-FR" dirty="0" err="1" smtClean="0"/>
+              <a:t>TaskManager</a:t>
+            </a:r>
+            <a:endParaRPr dirty="0"/>
           </a:p>
         </p:txBody>
       </p:sp>
@@ -3847,7 +4150,59 @@
             </a:pPr>
             <a:r>
               <a:rPr dirty="0"/>
-              <a:t>CI : compilation et tests</a:t>
+              <a:t>CI </a:t>
+            </a:r>
+            <a:r>
+              <a:rPr dirty="0" smtClean="0"/>
+              <a:t>:</a:t>
+            </a:r>
+            <a:r>
+              <a:rPr lang="fr-FR" dirty="0" smtClean="0"/>
+              <a:t> </a:t>
+            </a:r>
+            <a:r>
+              <a:rPr lang="fr-FR" i="1" dirty="0">
+                <a:solidFill>
+                  <a:srgbClr val="0070C0"/>
+                </a:solidFill>
+              </a:rPr>
+              <a:t>C</a:t>
+            </a:r>
+            <a:r>
+              <a:rPr lang="fr-FR" i="1" dirty="0" smtClean="0">
+                <a:solidFill>
+                  <a:srgbClr val="0070C0"/>
+                </a:solidFill>
+              </a:rPr>
+              <a:t>ontinue </a:t>
+            </a:r>
+            <a:r>
+              <a:rPr lang="fr-FR" i="1" dirty="0" err="1">
+                <a:solidFill>
+                  <a:srgbClr val="0070C0"/>
+                </a:solidFill>
+              </a:rPr>
+              <a:t>I</a:t>
+            </a:r>
+            <a:r>
+              <a:rPr lang="fr-FR" i="1" dirty="0" err="1" smtClean="0">
+                <a:solidFill>
+                  <a:srgbClr val="0070C0"/>
+                </a:solidFill>
+              </a:rPr>
+              <a:t>ntegration</a:t>
+            </a:r>
+            <a:r>
+              <a:rPr lang="fr-FR" dirty="0" smtClean="0"/>
+              <a:t>,</a:t>
+            </a:r>
+            <a:r>
+              <a:rPr dirty="0" smtClean="0"/>
+              <a:t> </a:t>
+            </a:r>
+            <a:r>
+              <a:rPr dirty="0"/>
+              <a:t>compilation et tests</a:t>
             </a:r>
           </a:p>
           <a:p>
@@ -3856,7 +4211,43 @@
             </a:pPr>
             <a:r>
               <a:rPr dirty="0"/>
-              <a:t>CD : build Docker et </a:t>
+              <a:t>CD : </a:t>
+            </a:r>
+            <a:r>
+              <a:rPr lang="fr-FR" i="1" dirty="0">
+                <a:solidFill>
+                  <a:srgbClr val="0070C0"/>
+                </a:solidFill>
+              </a:rPr>
+              <a:t>C</a:t>
+            </a:r>
+            <a:r>
+              <a:rPr lang="fr-FR" i="1" dirty="0" smtClean="0">
+                <a:solidFill>
+                  <a:srgbClr val="0070C0"/>
+                </a:solidFill>
+              </a:rPr>
+              <a:t>ontinue </a:t>
+            </a:r>
+            <a:r>
+              <a:rPr lang="fr-FR" i="1" dirty="0" err="1" smtClean="0">
+                <a:solidFill>
+                  <a:srgbClr val="0070C0"/>
+                </a:solidFill>
+              </a:rPr>
+              <a:t>Deployment</a:t>
+            </a:r>
+            <a:r>
+              <a:rPr lang="fr-FR" dirty="0" smtClean="0"/>
+              <a:t>, </a:t>
+            </a:r>
+            <a:r>
+              <a:rPr dirty="0" smtClean="0"/>
+              <a:t>build </a:t>
+            </a:r>
+            <a:r>
+              <a:rPr dirty="0"/>
+              <a:t>Docker et </a:t>
             </a:r>
             <a:r>
               <a:rPr dirty="0" err="1"/>
@@ -4863,24 +5254,66 @@
       </p:sp>
       <p:pic>
         <p:nvPicPr>
-          <p:cNvPr id="4" name="Image 3"/>
-          <p:cNvPicPr/>
+          <p:cNvPr id="1026" name="Picture 2"/>
+          <p:cNvPicPr>
+            <a:picLocks noChangeAspect="1" noChangeArrowheads="1"/>
+          </p:cNvPicPr>
           <p:nvPr/>
         </p:nvPicPr>
         <p:blipFill>
-          <a:blip r:embed="rId2"/>
+          <a:blip r:embed="rId2">
+            <a:extLst>
+              <a:ext uri="{28A0092B-C50C-407E-A947-70E740481C1C}">
+                <a14:useLocalDpi xmlns:a14="http://schemas.microsoft.com/office/drawing/2010/main" val="0"/>
+              </a:ext>
+            </a:extLst>
+          </a:blip>
+          <a:srcRect/>
           <a:stretch>
             <a:fillRect/>
           </a:stretch>
         </p:blipFill>
-        <p:spPr>
+        <p:spPr bwMode="auto">
           <a:xfrm>
-            <a:off x="686512" y="2009955"/>
-            <a:ext cx="5760720" cy="4408098"/>
+            <a:off x="648953" y="1989221"/>
+            <a:ext cx="6762499" cy="4532349"/>
           </a:xfrm>
           <a:prstGeom prst="rect">
             <a:avLst/>
           </a:prstGeom>
+          <a:noFill/>
+          <a:ln>
+            <a:noFill/>
+          </a:ln>
+          <a:effectLst/>
+          <a:extLst>
+            <a:ext uri="{909E8E84-426E-40DD-AFC4-6F175D3DCCD1}">
+              <a14:hiddenFill xmlns:a14="http://schemas.microsoft.com/office/drawing/2010/main">
+                <a:solidFill>
+                  <a:schemeClr val="accent1"/>
+                </a:solidFill>
+              </a14:hiddenFill>
+            </a:ext>
+            <a:ext uri="{91240B29-F687-4F45-9708-019B960494DF}">
+              <a14:hiddenLine xmlns:a14="http://schemas.microsoft.com/office/drawing/2010/main" w="9525">
+                <a:solidFill>
+                  <a:schemeClr val="tx1"/>
+                </a:solidFill>
+                <a:miter lim="800000"/>
+                <a:headEnd/>
+                <a:tailEnd/>
+              </a14:hiddenLine>
+            </a:ext>
+            <a:ext uri="{AF507438-7753-43E0-B8FC-AC1667EBCBE1}">
+              <a14:hiddenEffects xmlns:a14="http://schemas.microsoft.com/office/drawing/2010/main">
+                <a:effectLst>
+                  <a:outerShdw dist="35921" dir="2700000" algn="ctr" rotWithShape="0">
+                    <a:schemeClr val="bg2"/>
+                  </a:outerShdw>
+                </a:effectLst>
+              </a14:hiddenEffects>
+            </a:ext>
+          </a:extLst>
         </p:spPr>
       </p:pic>
     </p:spTree>
@@ -4917,58 +5350,18 @@
       </p:grpSpPr>
       <p:sp>
         <p:nvSpPr>
-          <p:cNvPr id="2" name="Titre 1"/>
-          <p:cNvSpPr>
-            <a:spLocks noGrp="1"/>
-          </p:cNvSpPr>
-          <p:nvPr>
-            <p:ph type="title"/>
+          <p:cNvPr id="3" name="Espace réservé du contenu 2"/>
+          <p:cNvSpPr>
+            <a:spLocks noGrp="1"/>
+          </p:cNvSpPr>
+          <p:nvPr>
+            <p:ph idx="1"/>
           </p:nvPr>
         </p:nvSpPr>
         <p:spPr>
           <a:xfrm>
-            <a:off x="457200" y="274638"/>
-            <a:ext cx="8229600" cy="786411"/>
-          </a:xfrm>
-        </p:spPr>
-        <p:txBody>
-          <a:bodyPr/>
-          <a:lstStyle/>
-          <a:p>
-            <a:r>
-              <a:rPr lang="fr-FR" dirty="0"/>
-              <a:t>Fichiers </a:t>
-            </a:r>
-            <a:r>
-              <a:rPr lang="fr-FR" dirty="0" err="1"/>
-              <a:t>DevOps</a:t>
-            </a:r>
-            <a:r>
-              <a:rPr lang="fr-FR" dirty="0"/>
-              <a:t> </a:t>
-            </a:r>
-            <a:r>
-              <a:rPr lang="fr-FR" dirty="0" smtClean="0"/>
-              <a:t>(2)</a:t>
-            </a:r>
-            <a:endParaRPr lang="fr-FR" dirty="0"/>
-          </a:p>
-        </p:txBody>
-      </p:sp>
-      <p:sp>
-        <p:nvSpPr>
-          <p:cNvPr id="3" name="Espace réservé du contenu 2"/>
-          <p:cNvSpPr>
-            <a:spLocks noGrp="1"/>
-          </p:cNvSpPr>
-          <p:nvPr>
-            <p:ph idx="1"/>
-          </p:nvPr>
-        </p:nvSpPr>
-        <p:spPr>
-          <a:xfrm>
-            <a:off x="457200" y="1155940"/>
-            <a:ext cx="8229600" cy="4970224"/>
+            <a:off x="457200" y="802106"/>
+            <a:ext cx="8229600" cy="5324058"/>
           </a:xfrm>
         </p:spPr>
         <p:txBody>
@@ -4977,151 +5370,50 @@
           </a:bodyPr>
           <a:lstStyle/>
           <a:p>
-            <a:pPr>
-              <a:defRPr sz="2200"/>
-            </a:pPr>
-            <a:r>
-              <a:rPr lang="fr-FR" dirty="0"/>
-              <a:t>devops_files.py et </a:t>
-            </a:r>
-            <a:r>
-              <a:rPr lang="fr-FR" dirty="0" smtClean="0"/>
-              <a:t>devops_ci.py</a:t>
-            </a:r>
-          </a:p>
-          <a:p>
-            <a:pPr marL="0" indent="0">
-              <a:buNone/>
-              <a:defRPr sz="2200"/>
-            </a:pPr>
-            <a:r>
-              <a:rPr lang="fr-FR" sz="1600" dirty="0"/>
-              <a:t>Le script </a:t>
-            </a:r>
-            <a:r>
-              <a:rPr lang="fr-FR" sz="1600" b="1" dirty="0"/>
-              <a:t>devops_files.py</a:t>
-            </a:r>
-            <a:r>
-              <a:rPr lang="fr-FR" sz="1600" dirty="0"/>
-              <a:t> prépare automatiquement les fichiers nécessaires au déploiement </a:t>
-            </a:r>
             <a:r>
               <a:rPr lang="fr-FR" sz="1600" dirty="0" err="1"/>
-              <a:t>DevOps</a:t>
-            </a:r>
-            <a:r>
-              <a:rPr lang="fr-FR" sz="1600" dirty="0"/>
-              <a:t>. Il génère, copie ou organise les ressources et les fichiers de configuration utilisés par Docker, </a:t>
-            </a:r>
-            <a:r>
-              <a:rPr lang="fr-FR" sz="1600" dirty="0" err="1"/>
-              <a:t>Kubernetes</a:t>
-            </a:r>
-            <a:r>
-              <a:rPr lang="fr-FR" sz="1600" dirty="0"/>
-              <a:t> et </a:t>
-            </a:r>
-            <a:r>
-              <a:rPr lang="fr-FR" sz="1600" dirty="0" err="1"/>
-              <a:t>GitHub</a:t>
-            </a:r>
-            <a:r>
-              <a:rPr lang="fr-FR" sz="1600" dirty="0"/>
-              <a:t> Actions. </a:t>
-            </a:r>
-          </a:p>
-          <a:p>
-            <a:pPr>
-              <a:defRPr sz="2200"/>
-            </a:pPr>
+              <a:t>c</a:t>
+            </a:r>
+            <a:r>
+              <a:rPr lang="fr-FR" sz="1600" dirty="0" err="1" smtClean="0"/>
+              <a:t>d.yml</a:t>
+            </a:r>
             <a:endParaRPr lang="fr-FR" sz="1600" dirty="0"/>
           </a:p>
-          <a:p>
-            <a:pPr marL="0" indent="0">
-              <a:buNone/>
-              <a:defRPr sz="2200"/>
-            </a:pPr>
-            <a:r>
-              <a:rPr lang="fr-FR" sz="1600" dirty="0"/>
-              <a:t>Le script </a:t>
-            </a:r>
-            <a:r>
-              <a:rPr lang="fr-FR" sz="1600" b="1" dirty="0"/>
-              <a:t>devops_ci.py</a:t>
-            </a:r>
-            <a:r>
-              <a:rPr lang="fr-FR" sz="1600" dirty="0"/>
-              <a:t> automatise certaines étapes de l'intégration continue, comme la préparation des </a:t>
-            </a:r>
-            <a:r>
-              <a:rPr lang="fr-FR" sz="1600" dirty="0" err="1"/>
-              <a:t>builds</a:t>
-            </a:r>
-            <a:r>
-              <a:rPr lang="fr-FR" sz="1600" dirty="0"/>
-              <a:t>, les vérifications ou l'exécution de tâches techniques avant le lancement du pipeline CI/CD. Il simplifie et standardise le processus de déploiement. </a:t>
-            </a:r>
-          </a:p>
-          <a:p>
-            <a:pPr>
-              <a:defRPr sz="2200"/>
-            </a:pPr>
-            <a:endParaRPr lang="fr-FR" dirty="0"/>
-          </a:p>
-          <a:p>
-            <a:pPr>
-              <a:defRPr sz="2200"/>
-            </a:pPr>
-            <a:r>
-              <a:rPr lang="fr-FR" dirty="0"/>
-              <a:t>.</a:t>
-            </a:r>
-            <a:r>
-              <a:rPr lang="fr-FR" dirty="0" err="1"/>
-              <a:t>env</a:t>
-            </a:r>
-            <a:r>
-              <a:rPr lang="fr-FR" dirty="0"/>
-              <a:t> et application-*.</a:t>
-            </a:r>
-            <a:r>
-              <a:rPr lang="fr-FR" dirty="0" err="1"/>
-              <a:t>yml</a:t>
-            </a:r>
-            <a:endParaRPr lang="fr-FR" dirty="0"/>
-          </a:p>
-          <a:p>
-            <a:pPr marL="0" indent="0">
-              <a:buNone/>
-            </a:pPr>
-            <a:r>
-              <a:rPr lang="fr-FR" sz="1700" dirty="0"/>
-              <a:t>centralise les variables d'environnement de l'application, telles que les ports, les mots de passe, les URL des services ou les paramètres de base de données. Il permet de modifier la configuration sans changer le code source. </a:t>
-            </a:r>
-          </a:p>
-          <a:p>
-            <a:endParaRPr lang="fr-FR" dirty="0"/>
-          </a:p>
-        </p:txBody>
-      </p:sp>
+        </p:txBody>
+      </p:sp>
+      <p:pic>
+        <p:nvPicPr>
+          <p:cNvPr id="4" name="Image 3"/>
+          <p:cNvPicPr/>
+          <p:nvPr/>
+        </p:nvPicPr>
+        <p:blipFill>
+          <a:blip r:embed="rId2"/>
+          <a:stretch>
+            <a:fillRect/>
+          </a:stretch>
+        </p:blipFill>
+        <p:spPr>
+          <a:xfrm>
+            <a:off x="686512" y="1291390"/>
+            <a:ext cx="6420141" cy="5021178"/>
+          </a:xfrm>
+          <a:prstGeom prst="rect">
+            <a:avLst/>
+          </a:prstGeom>
+        </p:spPr>
+      </p:pic>
     </p:spTree>
     <p:extLst>
       <p:ext uri="{BB962C8B-B14F-4D97-AF65-F5344CB8AC3E}">
-        <p14:creationId xmlns:p14="http://schemas.microsoft.com/office/powerpoint/2010/main" val="3472314947"/>
+        <p14:creationId xmlns:p14="http://schemas.microsoft.com/office/powerpoint/2010/main" val="4093953159"/>
       </p:ext>
     </p:extLst>
   </p:cSld>
   <p:clrMapOvr>
     <a:masterClrMapping/>
   </p:clrMapOvr>
-  <p:timing>
-    <p:tnLst>
-      <p:par>
-        <p:cTn id="1" dur="indefinite" restart="never" nodeType="tmRoot"/>
-      </p:par>
-    </p:tnLst>
-  </p:timing>
 </p:sld>
 </file>
 

</xml_diff>

<commit_message>
Mise à jour DevOps sans la vidéo
</commit_message>
<xml_diff>
--- a/video et fichiers à publier/Presentation_DevOps_TaskManager_Microservices.pptx
+++ b/video et fichiers à publier/Presentation_DevOps_TaskManager_Microservices.pptx
@@ -3719,6 +3719,13 @@
               <a:rPr lang="fr-FR" smtClean="0"/>
               <a:t>devops</a:t>
             </a:r>
+            <a:endParaRPr lang="fr-FR" dirty="0" smtClean="0"/>
+          </a:p>
+          <a:p>
+            <a:pPr marL="0" indent="0">
+              <a:buNone/>
+              <a:defRPr sz="2200"/>
+            </a:pPr>
             <a:endParaRPr lang="fr-FR" dirty="0" smtClean="0"/>
           </a:p>
           <a:p>

</xml_diff>

<commit_message>
Demo de devops de ce jour
</commit_message>
<xml_diff>
--- a/video et fichiers à publier/Presentation_DevOps_TaskManager_Microservices.pptx
+++ b/video et fichiers à publier/Presentation_DevOps_TaskManager_Microservices.pptx
@@ -3716,8 +3716,16 @@
               <a:t>Démo </a:t>
             </a:r>
             <a:r>
+              <a:rPr lang="fr-FR" dirty="0" err="1" smtClean="0"/>
+              <a:t>devops</a:t>
+            </a:r>
+            <a:r>
+              <a:rPr lang="fr-FR" dirty="0" smtClean="0"/>
+              <a:t> de </a:t>
+            </a:r>
+            <a:r>
               <a:rPr lang="fr-FR" smtClean="0"/>
-              <a:t>devops</a:t>
+              <a:t>ce jour</a:t>
             </a:r>
             <a:endParaRPr lang="fr-FR" dirty="0" smtClean="0"/>
           </a:p>

</xml_diff>